<commit_message>
Improve nearest word display and update report outputs
</commit_message>
<xml_diff>
--- a/presentations/NLP_Mini_Project_3_Khmer_Word_Embeddings_Presentation.pptx
+++ b/presentations/NLP_Mini_Project_3_Khmer_Word_Embeddings_Presentation.pptx
@@ -6155,16 +6155,762 @@
           </a:p>
         </p:txBody>
       </p:sp>
-      <p:sp>
-        <p:nvSpPr>
-          <p:cNvPr id="3" name="TextBox 2"/>
+      <p:graphicFrame>
+        <p:nvGraphicFramePr>
+          <p:cNvPr id="3" name="Table 2"/>
+          <p:cNvGraphicFramePr>
+            <a:graphicFrameLocks noGrp="1"/>
+          </p:cNvGraphicFramePr>
+          <p:nvPr/>
+        </p:nvGraphicFramePr>
+        <p:xfrm>
+          <a:off x="594360" y="1051560"/>
+          <a:ext cx="7132320" cy="3931920"/>
+        </p:xfrm>
+        <a:graphic>
+          <a:graphicData uri="http://schemas.openxmlformats.org/drawingml/2006/table">
+            <a:tbl>
+              <a:tblPr firstRow="1" bandRow="1">
+                <a:tableStyleId>{5C22544A-7EE6-4342-B048-85BDC9FD1C3A}</a:tableStyleId>
+              </a:tblPr>
+              <a:tblGrid>
+                <a:gridCol w="1783080"/>
+                <a:gridCol w="1783080"/>
+                <a:gridCol w="1783080"/>
+                <a:gridCol w="1783080"/>
+              </a:tblGrid>
+              <a:tr h="436880">
+                <a:tc>
+                  <a:txBody>
+                    <a:bodyPr/>
+                    <a:lstStyle/>
+                    <a:p>
+                      <a:pPr>
+                        <a:defRPr b="1" sz="900">
+                          <a:solidFill>
+                            <a:srgbClr val="FFFFFF"/>
+                          </a:solidFill>
+                        </a:defRPr>
+                      </a:pPr>
+                      <a:r>
+                        <a:t>Query</a:t>
+                      </a:r>
+                    </a:p>
+                  </a:txBody>
+                  <a:tcPr>
+                    <a:solidFill>
+                      <a:srgbClr val="0B1F3A"/>
+                    </a:solidFill>
+                  </a:tcPr>
+                </a:tc>
+                <a:tc>
+                  <a:txBody>
+                    <a:bodyPr/>
+                    <a:lstStyle/>
+                    <a:p>
+                      <a:pPr>
+                        <a:defRPr b="1" sz="900">
+                          <a:solidFill>
+                            <a:srgbClr val="FFFFFF"/>
+                          </a:solidFill>
+                        </a:defRPr>
+                      </a:pPr>
+                      <a:r>
+                        <a:t>Similar Word</a:t>
+                      </a:r>
+                    </a:p>
+                  </a:txBody>
+                  <a:tcPr>
+                    <a:solidFill>
+                      <a:srgbClr val="0B1F3A"/>
+                    </a:solidFill>
+                  </a:tcPr>
+                </a:tc>
+                <a:tc>
+                  <a:txBody>
+                    <a:bodyPr/>
+                    <a:lstStyle/>
+                    <a:p>
+                      <a:pPr>
+                        <a:defRPr b="1" sz="900">
+                          <a:solidFill>
+                            <a:srgbClr val="FFFFFF"/>
+                          </a:solidFill>
+                        </a:defRPr>
+                      </a:pPr>
+                      <a:r>
+                        <a:t>Freq.</a:t>
+                      </a:r>
+                    </a:p>
+                  </a:txBody>
+                  <a:tcPr>
+                    <a:solidFill>
+                      <a:srgbClr val="0B1F3A"/>
+                    </a:solidFill>
+                  </a:tcPr>
+                </a:tc>
+                <a:tc>
+                  <a:txBody>
+                    <a:bodyPr/>
+                    <a:lstStyle/>
+                    <a:p>
+                      <a:pPr>
+                        <a:defRPr b="1" sz="900">
+                          <a:solidFill>
+                            <a:srgbClr val="FFFFFF"/>
+                          </a:solidFill>
+                        </a:defRPr>
+                      </a:pPr>
+                      <a:r>
+                        <a:t>Cosine</a:t>
+                      </a:r>
+                    </a:p>
+                  </a:txBody>
+                  <a:tcPr>
+                    <a:solidFill>
+                      <a:srgbClr val="0B1F3A"/>
+                    </a:solidFill>
+                  </a:tcPr>
+                </a:tc>
+              </a:tr>
+              <a:tr h="436880">
+                <a:tc>
+                  <a:txBody>
+                    <a:bodyPr/>
+                    <a:lstStyle/>
+                    <a:p>
+                      <a:pPr>
+                        <a:defRPr sz="900">
+                          <a:solidFill>
+                            <a:srgbClr val="526070"/>
+                          </a:solidFill>
+                        </a:defRPr>
+                      </a:pPr>
+                      <a:r>
+                        <a:t>ប្រាសាទ</a:t>
+                      </a:r>
+                    </a:p>
+                  </a:txBody>
+                  <a:tcPr/>
+                </a:tc>
+                <a:tc>
+                  <a:txBody>
+                    <a:bodyPr/>
+                    <a:lstStyle/>
+                    <a:p>
+                      <a:pPr>
+                        <a:defRPr sz="900">
+                          <a:solidFill>
+                            <a:srgbClr val="526070"/>
+                          </a:solidFill>
+                        </a:defRPr>
+                      </a:pPr>
+                      <a:r>
+                        <a:t>សតវត្ស</a:t>
+                      </a:r>
+                    </a:p>
+                  </a:txBody>
+                  <a:tcPr/>
+                </a:tc>
+                <a:tc>
+                  <a:txBody>
+                    <a:bodyPr/>
+                    <a:lstStyle/>
+                    <a:p>
+                      <a:pPr>
+                        <a:defRPr sz="900">
+                          <a:solidFill>
+                            <a:srgbClr val="526070"/>
+                          </a:solidFill>
+                        </a:defRPr>
+                      </a:pPr>
+                      <a:r>
+                        <a:t>17</a:t>
+                      </a:r>
+                    </a:p>
+                  </a:txBody>
+                  <a:tcPr/>
+                </a:tc>
+                <a:tc>
+                  <a:txBody>
+                    <a:bodyPr/>
+                    <a:lstStyle/>
+                    <a:p>
+                      <a:pPr>
+                        <a:defRPr sz="900">
+                          <a:solidFill>
+                            <a:srgbClr val="526070"/>
+                          </a:solidFill>
+                        </a:defRPr>
+                      </a:pPr>
+                      <a:r>
+                        <a:t>0.5914</a:t>
+                      </a:r>
+                    </a:p>
+                  </a:txBody>
+                  <a:tcPr/>
+                </a:tc>
+              </a:tr>
+              <a:tr h="436880">
+                <a:tc>
+                  <a:txBody>
+                    <a:bodyPr/>
+                    <a:lstStyle/>
+                    <a:p>
+                      <a:pPr>
+                        <a:defRPr sz="900">
+                          <a:solidFill>
+                            <a:srgbClr val="526070"/>
+                          </a:solidFill>
+                        </a:defRPr>
+                      </a:pPr>
+                      <a:r>
+                        <a:t>ប្រាសាទ</a:t>
+                      </a:r>
+                    </a:p>
+                  </a:txBody>
+                  <a:tcPr/>
+                </a:tc>
+                <a:tc>
+                  <a:txBody>
+                    <a:bodyPr/>
+                    <a:lstStyle/>
+                    <a:p>
+                      <a:pPr>
+                        <a:defRPr sz="900">
+                          <a:solidFill>
+                            <a:srgbClr val="526070"/>
+                          </a:solidFill>
+                        </a:defRPr>
+                      </a:pPr>
+                      <a:r>
+                        <a:t>ប្រទេស</a:t>
+                      </a:r>
+                    </a:p>
+                  </a:txBody>
+                  <a:tcPr/>
+                </a:tc>
+                <a:tc>
+                  <a:txBody>
+                    <a:bodyPr/>
+                    <a:lstStyle/>
+                    <a:p>
+                      <a:pPr>
+                        <a:defRPr sz="900">
+                          <a:solidFill>
+                            <a:srgbClr val="526070"/>
+                          </a:solidFill>
+                        </a:defRPr>
+                      </a:pPr>
+                      <a:r>
+                        <a:t>17</a:t>
+                      </a:r>
+                    </a:p>
+                  </a:txBody>
+                  <a:tcPr/>
+                </a:tc>
+                <a:tc>
+                  <a:txBody>
+                    <a:bodyPr/>
+                    <a:lstStyle/>
+                    <a:p>
+                      <a:pPr>
+                        <a:defRPr sz="900">
+                          <a:solidFill>
+                            <a:srgbClr val="526070"/>
+                          </a:solidFill>
+                        </a:defRPr>
+                      </a:pPr>
+                      <a:r>
+                        <a:t>0.5365</a:t>
+                      </a:r>
+                    </a:p>
+                  </a:txBody>
+                  <a:tcPr/>
+                </a:tc>
+              </a:tr>
+              <a:tr h="436880">
+                <a:tc>
+                  <a:txBody>
+                    <a:bodyPr/>
+                    <a:lstStyle/>
+                    <a:p>
+                      <a:pPr>
+                        <a:defRPr sz="900">
+                          <a:solidFill>
+                            <a:srgbClr val="526070"/>
+                          </a:solidFill>
+                        </a:defRPr>
+                      </a:pPr>
+                      <a:r>
+                        <a:t>ប្រាសាទ</a:t>
+                      </a:r>
+                    </a:p>
+                  </a:txBody>
+                  <a:tcPr/>
+                </a:tc>
+                <a:tc>
+                  <a:txBody>
+                    <a:bodyPr/>
+                    <a:lstStyle/>
+                    <a:p>
+                      <a:pPr>
+                        <a:defRPr sz="900">
+                          <a:solidFill>
+                            <a:srgbClr val="526070"/>
+                          </a:solidFill>
+                        </a:defRPr>
+                      </a:pPr>
+                      <a:r>
+                        <a:t>តំណាង</a:t>
+                      </a:r>
+                    </a:p>
+                  </a:txBody>
+                  <a:tcPr/>
+                </a:tc>
+                <a:tc>
+                  <a:txBody>
+                    <a:bodyPr/>
+                    <a:lstStyle/>
+                    <a:p>
+                      <a:pPr>
+                        <a:defRPr sz="900">
+                          <a:solidFill>
+                            <a:srgbClr val="526070"/>
+                          </a:solidFill>
+                        </a:defRPr>
+                      </a:pPr>
+                      <a:r>
+                        <a:t>13</a:t>
+                      </a:r>
+                    </a:p>
+                  </a:txBody>
+                  <a:tcPr/>
+                </a:tc>
+                <a:tc>
+                  <a:txBody>
+                    <a:bodyPr/>
+                    <a:lstStyle/>
+                    <a:p>
+                      <a:pPr>
+                        <a:defRPr sz="900">
+                          <a:solidFill>
+                            <a:srgbClr val="526070"/>
+                          </a:solidFill>
+                        </a:defRPr>
+                      </a:pPr>
+                      <a:r>
+                        <a:t>0.5147</a:t>
+                      </a:r>
+                    </a:p>
+                  </a:txBody>
+                  <a:tcPr/>
+                </a:tc>
+              </a:tr>
+              <a:tr h="436880">
+                <a:tc>
+                  <a:txBody>
+                    <a:bodyPr/>
+                    <a:lstStyle/>
+                    <a:p>
+                      <a:pPr>
+                        <a:defRPr sz="900">
+                          <a:solidFill>
+                            <a:srgbClr val="526070"/>
+                          </a:solidFill>
+                        </a:defRPr>
+                      </a:pPr>
+                      <a:r>
+                        <a:t>ប្រាសាទ</a:t>
+                      </a:r>
+                    </a:p>
+                  </a:txBody>
+                  <a:tcPr/>
+                </a:tc>
+                <a:tc>
+                  <a:txBody>
+                    <a:bodyPr/>
+                    <a:lstStyle/>
+                    <a:p>
+                      <a:pPr>
+                        <a:defRPr sz="900">
+                          <a:solidFill>
+                            <a:srgbClr val="526070"/>
+                          </a:solidFill>
+                        </a:defRPr>
+                      </a:pPr>
+                      <a:r>
+                        <a:t>ផ្នែក</a:t>
+                      </a:r>
+                    </a:p>
+                  </a:txBody>
+                  <a:tcPr/>
+                </a:tc>
+                <a:tc>
+                  <a:txBody>
+                    <a:bodyPr/>
+                    <a:lstStyle/>
+                    <a:p>
+                      <a:pPr>
+                        <a:defRPr sz="900">
+                          <a:solidFill>
+                            <a:srgbClr val="526070"/>
+                          </a:solidFill>
+                        </a:defRPr>
+                      </a:pPr>
+                      <a:r>
+                        <a:t>18</a:t>
+                      </a:r>
+                    </a:p>
+                  </a:txBody>
+                  <a:tcPr/>
+                </a:tc>
+                <a:tc>
+                  <a:txBody>
+                    <a:bodyPr/>
+                    <a:lstStyle/>
+                    <a:p>
+                      <a:pPr>
+                        <a:defRPr sz="900">
+                          <a:solidFill>
+                            <a:srgbClr val="526070"/>
+                          </a:solidFill>
+                        </a:defRPr>
+                      </a:pPr>
+                      <a:r>
+                        <a:t>0.4326</a:t>
+                      </a:r>
+                    </a:p>
+                  </a:txBody>
+                  <a:tcPr/>
+                </a:tc>
+              </a:tr>
+              <a:tr h="436880">
+                <a:tc>
+                  <a:txBody>
+                    <a:bodyPr/>
+                    <a:lstStyle/>
+                    <a:p>
+                      <a:pPr>
+                        <a:defRPr sz="900">
+                          <a:solidFill>
+                            <a:srgbClr val="526070"/>
+                          </a:solidFill>
+                        </a:defRPr>
+                      </a:pPr>
+                      <a:r>
+                        <a:t>ប្រាសាទ</a:t>
+                      </a:r>
+                    </a:p>
+                  </a:txBody>
+                  <a:tcPr/>
+                </a:tc>
+                <a:tc>
+                  <a:txBody>
+                    <a:bodyPr/>
+                    <a:lstStyle/>
+                    <a:p>
+                      <a:pPr>
+                        <a:defRPr sz="900">
+                          <a:solidFill>
+                            <a:srgbClr val="526070"/>
+                          </a:solidFill>
+                        </a:defRPr>
+                      </a:pPr>
+                      <a:r>
+                        <a:t>ខាងត្បូង</a:t>
+                      </a:r>
+                    </a:p>
+                  </a:txBody>
+                  <a:tcPr/>
+                </a:tc>
+                <a:tc>
+                  <a:txBody>
+                    <a:bodyPr/>
+                    <a:lstStyle/>
+                    <a:p>
+                      <a:pPr>
+                        <a:defRPr sz="900">
+                          <a:solidFill>
+                            <a:srgbClr val="526070"/>
+                          </a:solidFill>
+                        </a:defRPr>
+                      </a:pPr>
+                      <a:r>
+                        <a:t>12</a:t>
+                      </a:r>
+                    </a:p>
+                  </a:txBody>
+                  <a:tcPr/>
+                </a:tc>
+                <a:tc>
+                  <a:txBody>
+                    <a:bodyPr/>
+                    <a:lstStyle/>
+                    <a:p>
+                      <a:pPr>
+                        <a:defRPr sz="900">
+                          <a:solidFill>
+                            <a:srgbClr val="526070"/>
+                          </a:solidFill>
+                        </a:defRPr>
+                      </a:pPr>
+                      <a:r>
+                        <a:t>0.4271</a:t>
+                      </a:r>
+                    </a:p>
+                  </a:txBody>
+                  <a:tcPr/>
+                </a:tc>
+              </a:tr>
+              <a:tr h="436880">
+                <a:tc>
+                  <a:txBody>
+                    <a:bodyPr/>
+                    <a:lstStyle/>
+                    <a:p>
+                      <a:pPr>
+                        <a:defRPr sz="900">
+                          <a:solidFill>
+                            <a:srgbClr val="526070"/>
+                          </a:solidFill>
+                        </a:defRPr>
+                      </a:pPr>
+                      <a:r>
+                        <a:t>ប្រាសាទ</a:t>
+                      </a:r>
+                    </a:p>
+                  </a:txBody>
+                  <a:tcPr/>
+                </a:tc>
+                <a:tc>
+                  <a:txBody>
+                    <a:bodyPr/>
+                    <a:lstStyle/>
+                    <a:p>
+                      <a:pPr>
+                        <a:defRPr sz="900">
+                          <a:solidFill>
+                            <a:srgbClr val="526070"/>
+                          </a:solidFill>
+                        </a:defRPr>
+                      </a:pPr>
+                      <a:r>
+                        <a:t>ខាងកើត</a:t>
+                      </a:r>
+                    </a:p>
+                  </a:txBody>
+                  <a:tcPr/>
+                </a:tc>
+                <a:tc>
+                  <a:txBody>
+                    <a:bodyPr/>
+                    <a:lstStyle/>
+                    <a:p>
+                      <a:pPr>
+                        <a:defRPr sz="900">
+                          <a:solidFill>
+                            <a:srgbClr val="526070"/>
+                          </a:solidFill>
+                        </a:defRPr>
+                      </a:pPr>
+                      <a:r>
+                        <a:t>16</a:t>
+                      </a:r>
+                    </a:p>
+                  </a:txBody>
+                  <a:tcPr/>
+                </a:tc>
+                <a:tc>
+                  <a:txBody>
+                    <a:bodyPr/>
+                    <a:lstStyle/>
+                    <a:p>
+                      <a:pPr>
+                        <a:defRPr sz="900">
+                          <a:solidFill>
+                            <a:srgbClr val="526070"/>
+                          </a:solidFill>
+                        </a:defRPr>
+                      </a:pPr>
+                      <a:r>
+                        <a:t>0.4234</a:t>
+                      </a:r>
+                    </a:p>
+                  </a:txBody>
+                  <a:tcPr/>
+                </a:tc>
+              </a:tr>
+              <a:tr h="436880">
+                <a:tc>
+                  <a:txBody>
+                    <a:bodyPr/>
+                    <a:lstStyle/>
+                    <a:p>
+                      <a:pPr>
+                        <a:defRPr sz="900">
+                          <a:solidFill>
+                            <a:srgbClr val="526070"/>
+                          </a:solidFill>
+                        </a:defRPr>
+                      </a:pPr>
+                      <a:r>
+                        <a:t>ប្រាសាទ</a:t>
+                      </a:r>
+                    </a:p>
+                  </a:txBody>
+                  <a:tcPr/>
+                </a:tc>
+                <a:tc>
+                  <a:txBody>
+                    <a:bodyPr/>
+                    <a:lstStyle/>
+                    <a:p>
+                      <a:pPr>
+                        <a:defRPr sz="900">
+                          <a:solidFill>
+                            <a:srgbClr val="526070"/>
+                          </a:solidFill>
+                        </a:defRPr>
+                      </a:pPr>
+                      <a:r>
+                        <a:t>អង្គរ</a:t>
+                      </a:r>
+                    </a:p>
+                  </a:txBody>
+                  <a:tcPr/>
+                </a:tc>
+                <a:tc>
+                  <a:txBody>
+                    <a:bodyPr/>
+                    <a:lstStyle/>
+                    <a:p>
+                      <a:pPr>
+                        <a:defRPr sz="900">
+                          <a:solidFill>
+                            <a:srgbClr val="526070"/>
+                          </a:solidFill>
+                        </a:defRPr>
+                      </a:pPr>
+                      <a:r>
+                        <a:t>58</a:t>
+                      </a:r>
+                    </a:p>
+                  </a:txBody>
+                  <a:tcPr/>
+                </a:tc>
+                <a:tc>
+                  <a:txBody>
+                    <a:bodyPr/>
+                    <a:lstStyle/>
+                    <a:p>
+                      <a:pPr>
+                        <a:defRPr sz="900">
+                          <a:solidFill>
+                            <a:srgbClr val="526070"/>
+                          </a:solidFill>
+                        </a:defRPr>
+                      </a:pPr>
+                      <a:r>
+                        <a:t>0.4173</a:t>
+                      </a:r>
+                    </a:p>
+                  </a:txBody>
+                  <a:tcPr/>
+                </a:tc>
+              </a:tr>
+              <a:tr h="436880">
+                <a:tc>
+                  <a:txBody>
+                    <a:bodyPr/>
+                    <a:lstStyle/>
+                    <a:p>
+                      <a:pPr>
+                        <a:defRPr sz="900">
+                          <a:solidFill>
+                            <a:srgbClr val="526070"/>
+                          </a:solidFill>
+                        </a:defRPr>
+                      </a:pPr>
+                      <a:r>
+                        <a:t>ប្រាសាទ</a:t>
+                      </a:r>
+                    </a:p>
+                  </a:txBody>
+                  <a:tcPr/>
+                </a:tc>
+                <a:tc>
+                  <a:txBody>
+                    <a:bodyPr/>
+                    <a:lstStyle/>
+                    <a:p>
+                      <a:pPr>
+                        <a:defRPr sz="900">
+                          <a:solidFill>
+                            <a:srgbClr val="526070"/>
+                          </a:solidFill>
+                        </a:defRPr>
+                      </a:pPr>
+                      <a:r>
+                        <a:t>ស្ថិត</a:t>
+                      </a:r>
+                    </a:p>
+                  </a:txBody>
+                  <a:tcPr/>
+                </a:tc>
+                <a:tc>
+                  <a:txBody>
+                    <a:bodyPr/>
+                    <a:lstStyle/>
+                    <a:p>
+                      <a:pPr>
+                        <a:defRPr sz="900">
+                          <a:solidFill>
+                            <a:srgbClr val="526070"/>
+                          </a:solidFill>
+                        </a:defRPr>
+                      </a:pPr>
+                      <a:r>
+                        <a:t>24</a:t>
+                      </a:r>
+                    </a:p>
+                  </a:txBody>
+                  <a:tcPr/>
+                </a:tc>
+                <a:tc>
+                  <a:txBody>
+                    <a:bodyPr/>
+                    <a:lstStyle/>
+                    <a:p>
+                      <a:pPr>
+                        <a:defRPr sz="900">
+                          <a:solidFill>
+                            <a:srgbClr val="526070"/>
+                          </a:solidFill>
+                        </a:defRPr>
+                      </a:pPr>
+                      <a:r>
+                        <a:t>0.4151</a:t>
+                      </a:r>
+                    </a:p>
+                  </a:txBody>
+                  <a:tcPr/>
+                </a:tc>
+              </a:tr>
+            </a:tbl>
+          </a:graphicData>
+        </a:graphic>
+      </p:graphicFrame>
+      <p:sp>
+        <p:nvSpPr>
+          <p:cNvPr id="4" name="TextBox 3"/>
           <p:cNvSpPr txBox="1"/>
           <p:nvPr/>
         </p:nvSpPr>
         <p:spPr>
           <a:xfrm>
-            <a:off x="731520" y="1143000"/>
-            <a:ext cx="5486400" cy="4754880"/>
+            <a:off x="8046720" y="1234440"/>
+            <a:ext cx="3749039" cy="3474720"/>
           </a:xfrm>
           <a:prstGeom prst="rect">
             <a:avLst/>
@@ -6178,7 +6924,7 @@
           <a:lstStyle/>
           <a:p>
             <a:pPr>
-              <a:defRPr sz="2000">
+              <a:defRPr sz="1600">
                 <a:solidFill>
                   <a:srgbClr val="526070"/>
                 </a:solidFill>
@@ -6190,7 +6936,7 @@
           </a:p>
           <a:p>
             <a:pPr>
-              <a:defRPr sz="2000">
+              <a:defRPr sz="1600">
                 <a:solidFill>
                   <a:srgbClr val="526070"/>
                 </a:solidFill>
@@ -6202,14 +6948,14 @@
           </a:p>
           <a:p>
             <a:pPr>
-              <a:defRPr sz="2000">
+              <a:defRPr sz="1600">
                 <a:solidFill>
                   <a:srgbClr val="526070"/>
                 </a:solidFill>
               </a:defRPr>
             </a:pPr>
             <a:r>
-              <a:t>Small corpus means nearest words are not always synonyms.</a:t>
+              <a:t>Display filtering hides &lt;UNK&gt; and common function words for clearer interpretation.</a:t>
             </a:r>
           </a:p>
         </p:txBody>

</xml_diff>